<commit_message>
Tạo bộ slide bài giảng Tuần 03 cho 9 khối lớp, cập nhật bộ ảnh AI và LBG Tuần 03
</commit_message>
<xml_diff>
--- a/KHBD_Tin_học/Lớp_6/Tuần_02/Slide_Tin_hoc_Lop_6_Bai01_Thong_tin_va_du_lieu.pptx
+++ b/KHBD_Tin_học/Lớp_6/Tuần_02/Slide_Tin_hoc_Lop_6_Bai01_Thong_tin_va_du_lieu.pptx
@@ -3553,7 +3553,7 @@
       </p:sp>
       <p:pic>
         <p:nvPicPr>
-          <p:cNvPr id="6" name="Picture 5" descr="bai1_p10_img1.png"/>
+          <p:cNvPr id="6" name="Picture 5" descr="cover_lop6.jpg"/>
           <p:cNvPicPr>
             <a:picLocks noChangeAspect="1"/>
           </p:cNvPicPr>
@@ -3911,7 +3911,7 @@
       </p:sp>
       <p:pic>
         <p:nvPicPr>
-          <p:cNvPr id="9" name="Picture 8" descr="bai1_p10_img1.png"/>
+          <p:cNvPr id="9" name="Picture 8" descr="warmup_lop6.jpg"/>
           <p:cNvPicPr>
             <a:picLocks noChangeAspect="1"/>
           </p:cNvPicPr>
@@ -4200,7 +4200,7 @@
       </p:sp>
       <p:pic>
         <p:nvPicPr>
-          <p:cNvPr id="8" name="Picture 7" descr="bai1_p10_img1.png"/>
+          <p:cNvPr id="8" name="Picture 7" descr="learn1_lop6.jpg"/>
           <p:cNvPicPr>
             <a:picLocks noChangeAspect="1"/>
           </p:cNvPicPr>
@@ -4347,7 +4347,7 @@
       </p:sp>
       <p:pic>
         <p:nvPicPr>
-          <p:cNvPr id="12" name="Picture 11" descr="bai1_p11_img1.png"/>
+          <p:cNvPr id="12" name="Picture 11" descr="learn2_lop6.jpg"/>
           <p:cNvPicPr>
             <a:picLocks noChangeAspect="1"/>
           </p:cNvPicPr>
@@ -4494,7 +4494,7 @@
       </p:sp>
       <p:pic>
         <p:nvPicPr>
-          <p:cNvPr id="16" name="Picture 15" descr="bai1_p12_img1.png"/>
+          <p:cNvPr id="16" name="Picture 15" descr="learn3_lop6.jpg"/>
           <p:cNvPicPr>
             <a:picLocks noChangeAspect="1"/>
           </p:cNvPicPr>
@@ -4818,7 +4818,7 @@
       </p:sp>
       <p:pic>
         <p:nvPicPr>
-          <p:cNvPr id="8" name="Picture 7" descr="bai1_p13_img1.png"/>
+          <p:cNvPr id="8" name="Picture 7" descr="learn2_lop6.jpg"/>
           <p:cNvPicPr>
             <a:picLocks noChangeAspect="1"/>
           </p:cNvPicPr>
@@ -4965,7 +4965,7 @@
       </p:sp>
       <p:pic>
         <p:nvPicPr>
-          <p:cNvPr id="12" name="Picture 11" descr="bai1_p6_img1.png"/>
+          <p:cNvPr id="12" name="Picture 11" descr="learn3_lop6.jpg"/>
           <p:cNvPicPr>
             <a:picLocks noChangeAspect="1"/>
           </p:cNvPicPr>
@@ -5112,7 +5112,7 @@
       </p:sp>
       <p:pic>
         <p:nvPicPr>
-          <p:cNvPr id="16" name="Picture 15" descr="bai1_p7_img1.png"/>
+          <p:cNvPr id="16" name="Picture 15" descr="warmup_lop6.jpg"/>
           <p:cNvPicPr>
             <a:picLocks noChangeAspect="1"/>
           </p:cNvPicPr>
@@ -5436,7 +5436,7 @@
       </p:sp>
       <p:pic>
         <p:nvPicPr>
-          <p:cNvPr id="8" name="Picture 7" descr="bai1_p8_img1.png"/>
+          <p:cNvPr id="8" name="Picture 7" descr="activity_lop6.jpg"/>
           <p:cNvPicPr>
             <a:picLocks noChangeAspect="1"/>
           </p:cNvPicPr>
@@ -5583,7 +5583,7 @@
       </p:sp>
       <p:pic>
         <p:nvPicPr>
-          <p:cNvPr id="12" name="Picture 11" descr="bai1_p9_img1.png"/>
+          <p:cNvPr id="12" name="Picture 11" descr="cover_lop6.jpg"/>
           <p:cNvPicPr>
             <a:picLocks noChangeAspect="1"/>
           </p:cNvPicPr>
@@ -5730,7 +5730,7 @@
       </p:sp>
       <p:pic>
         <p:nvPicPr>
-          <p:cNvPr id="16" name="Picture 15" descr="bai1_p10_img1.png"/>
+          <p:cNvPr id="16" name="Picture 15" descr="learn1_lop6.jpg"/>
           <p:cNvPicPr>
             <a:picLocks noChangeAspect="1"/>
           </p:cNvPicPr>
@@ -6050,7 +6050,7 @@
       </p:sp>
       <p:pic>
         <p:nvPicPr>
-          <p:cNvPr id="8" name="Picture 7" descr="bai1_p10_img1.png"/>
+          <p:cNvPr id="8" name="Picture 7" descr="activity_lop6.jpg"/>
           <p:cNvPicPr>
             <a:picLocks noChangeAspect="1"/>
           </p:cNvPicPr>
@@ -6154,7 +6154,7 @@
       </p:sp>
       <p:pic>
         <p:nvPicPr>
-          <p:cNvPr id="11" name="Picture 10" descr="bai1_p11_img1.png"/>
+          <p:cNvPr id="11" name="Picture 10" descr="cover_lop6.jpg"/>
           <p:cNvPicPr>
             <a:picLocks noChangeAspect="1"/>
           </p:cNvPicPr>
@@ -6258,7 +6258,7 @@
       </p:sp>
       <p:pic>
         <p:nvPicPr>
-          <p:cNvPr id="14" name="Picture 13" descr="bai1_p12_img1.png"/>
+          <p:cNvPr id="14" name="Picture 13" descr="learn1_lop6.jpg"/>
           <p:cNvPicPr>
             <a:picLocks noChangeAspect="1"/>
           </p:cNvPicPr>
@@ -6362,7 +6362,7 @@
       </p:sp>
       <p:pic>
         <p:nvPicPr>
-          <p:cNvPr id="17" name="Picture 16" descr="bai1_p13_img1.png"/>
+          <p:cNvPr id="17" name="Picture 16" descr="learn2_lop6.jpg"/>
           <p:cNvPicPr>
             <a:picLocks noChangeAspect="1"/>
           </p:cNvPicPr>
@@ -7113,7 +7113,7 @@
       </p:sp>
       <p:pic>
         <p:nvPicPr>
-          <p:cNvPr id="9" name="Picture 8" descr="bai1_p10_img1.png"/>
+          <p:cNvPr id="9" name="Picture 8" descr="activity_lop6.jpg"/>
           <p:cNvPicPr>
             <a:picLocks noChangeAspect="1"/>
           </p:cNvPicPr>

</xml_diff>